<commit_message>
demo: R4 corrected to the current MiniRocket result (AUC 0.97 vs agreement 0.86), backup deck and DEMO_DAY.md
The deck's R4 slide and DEMO_DAY.md quoted the queue-25 preliminary (0.79 vs 0.83), superseded by
docs/rq_roundA_2/findings/rq1b-minirocket-2026-10-20.md: leave-one-recording-out on 2,456 events + 3,000
windows; on the 1,689 queue candidates AUC 0.97 (bal. acc. 0.92) vs detector agreement 0.86 and size+noise 0.90.
Docs only; after the 09:00 freeze, no code, dist or bridge touched.

Co-Authored-By: Claude Opus 5.5 <noreply@anthropic.com>
</commit_message>
<xml_diff>
--- a/docs/demo/UndergroundBrains_backup.pptx
+++ b/docs/demo/UndergroundBrains_backup.pptx
@@ -133,12 +133,12 @@
   <p:extLst>
     <p:ext uri="{521415D9-36F7-43E2-AB2F-B90AF26B5E84}">
       <p14:sectionLst xmlns:p14="http://schemas.microsoft.com/office/powerpoint/2010/main">
-        <p14:section name="Opening" id="{f3d2d6e0-9622-2530-6f6a-842b8f1f22dc}">
+        <p14:section name="Opening" id="{4fd5e24a-f136-f98b-5421-2e96925754c7}">
           <p14:sldIdLst>
             <p14:sldId id="256"/>
           </p14:sldIdLst>
         </p14:section>
-        <p14:section name="Walkthrough 1" id="{af514638-5d5e-7343-212f-0c9dc2a93199}">
+        <p14:section name="Walkthrough 1" id="{ab3f4331-9fa0-ac21-f8b8-3310e0a5235c}">
           <p14:sldIdLst>
             <p14:sldId id="257"/>
             <p14:sldId id="258"/>
@@ -147,7 +147,7 @@
             <p14:sldId id="261"/>
           </p14:sldIdLst>
         </p14:section>
-        <p14:section name="Walkthrough 2" id="{3c86c08d-1926-940e-acc0-440abd9c86a7}">
+        <p14:section name="Walkthrough 2" id="{6a3bf3f9-f284-e3a5-f8ec-2c33ff35b26b}">
           <p14:sldIdLst>
             <p14:sldId id="262"/>
             <p14:sldId id="263"/>
@@ -157,7 +157,7 @@
             <p14:sldId id="267"/>
           </p14:sldIdLst>
         </p14:section>
-        <p14:section name="Walkthrough 3" id="{daaccb36-aaa7-4aa8-8c64-3a79be67273a}">
+        <p14:section name="Walkthrough 3" id="{a2d54906-322f-a460-a8c8-6171bb5ff6db}">
           <p14:sldIdLst>
             <p14:sldId id="268"/>
             <p14:sldId id="269"/>
@@ -168,7 +168,7 @@
             <p14:sldId id="274"/>
           </p14:sldIdLst>
         </p14:section>
-        <p14:section name="Results" id="{dbf35d46-50ba-eb2b-35bc-a1f33c66f15a}">
+        <p14:section name="Results" id="{f0a7fbc7-df22-3d75-f361-a8df5c561bc2}">
           <p14:sldIdLst>
             <p14:sldId id="275"/>
             <p14:sldId id="276"/>
@@ -179,7 +179,7 @@
             <p14:sldId id="281"/>
           </p14:sldIdLst>
         </p14:section>
-        <p14:section name="Close" id="{cc6443b9-8d76-e9b0-7555-18e1278ab36f}">
+        <p14:section name="Close" id="{99456d3e-b2ae-523c-fafd-35c637c16349}">
           <p14:sldIdLst>
             <p14:sldId id="282"/>
           </p14:sldIdLst>
@@ -475,6 +475,310 @@
 </c:chartSpace>
 </file>
 
+<file path=ppt/charts/chart2.xml><?xml version="1.0" encoding="utf-8"?>
+<c:chartSpace xmlns:c="http://schemas.openxmlformats.org/drawingml/2006/chart" xmlns:a="http://schemas.openxmlformats.org/drawingml/2006/main" xmlns:r="http://schemas.openxmlformats.org/officeDocument/2006/relationships">
+  <c:date1904 val="0"/>
+  <c:roundedCorners val="1"/>
+  <c:chart>
+    <c:title>
+      <c:tx>
+        <c:rich>
+          <a:bodyPr/>
+          <a:lstStyle/>
+          <a:p>
+            <a:pPr>
+              <a:defRPr sz="1200" b="0" i="0" u="none" strike="noStrike">
+                <a:solidFill>
+                  <a:srgbClr val="1F1A17"/>
+                </a:solidFill>
+                <a:latin typeface="+mn-lt"/>
+              </a:defRPr>
+            </a:pPr>
+            <a:r>
+              <a:rPr sz="1200" b="0" i="0" u="none" strike="noStrike">
+                <a:solidFill>
+                  <a:srgbClr val="1F1A17"/>
+                </a:solidFill>
+                <a:latin typeface="+mn-lt"/>
+              </a:rPr>
+              <a:t>AUC on recordings the model never saw (1,689 candidates)</a:t>
+            </a:r>
+          </a:p>
+        </c:rich>
+      </c:tx>
+      <c:layout/>
+      <c:overlay val="0"/>
+    </c:title>
+    <c:autoTitleDeleted val="0"/>
+    <c:plotArea>
+      <c:layout/>
+      <c:barChart>
+        <c:barDir val="bar"/>
+        <c:grouping val="clustered"/>
+        <c:varyColors val="0"/>
+        <c:ser>
+          <c:idx val="0"/>
+          <c:order val="0"/>
+          <c:tx>
+            <c:strRef>
+              <c:f>Sheet1!$B$1</c:f>
+              <c:strCache>
+                <c:ptCount val="1"/>
+                <c:pt idx="0">
+                  <c:v>AUC</c:v>
+                </c:pt>
+              </c:strCache>
+            </c:strRef>
+          </c:tx>
+          <c:spPr>
+            <a:solidFill>
+              <a:srgbClr val="3E8E5E"/>
+            </a:solidFill>
+            <a:effectLst/>
+          </c:spPr>
+          <c:invertIfNegative val="0"/>
+          <c:dLbls>
+            <c:numFmt formatCode="0.00" sourceLinked="0"/>
+            <c:txPr>
+              <a:bodyPr/>
+              <a:lstStyle/>
+              <a:p>
+                <a:pPr>
+                  <a:defRPr b="0" i="0" strike="noStrike" sz="1200" u="none">
+                    <a:solidFill>
+                      <a:srgbClr val="1F1A17"/>
+                    </a:solidFill>
+                    <a:latin typeface="+mn-lt"/>
+                  </a:defRPr>
+                </a:pPr>
+              </a:p>
+            </c:txPr>
+            <c:showLegendKey val="0"/>
+            <c:showVal val="1"/>
+            <c:showCatName val="0"/>
+            <c:showSerName val="0"/>
+            <c:showPercent val="0"/>
+            <c:showBubbleSize val="0"/>
+            <c:showLeaderLines val="0"/>
+          </c:dLbls>
+          <c:dPt>
+            <c:idx val="0"/>
+            <c:invertIfNegative val="0"/>
+            <c:bubble3D val="0"/>
+            <c:spPr>
+              <a:solidFill>
+                <a:srgbClr val="3E8E5E"/>
+              </a:solidFill>
+              <a:effectLst/>
+            </c:spPr>
+          </c:dPt>
+          <c:dPt>
+            <c:idx val="1"/>
+            <c:invertIfNegative val="0"/>
+            <c:bubble3D val="0"/>
+            <c:spPr>
+              <a:solidFill>
+                <a:srgbClr val="8C8C84"/>
+              </a:solidFill>
+              <a:effectLst/>
+            </c:spPr>
+          </c:dPt>
+          <c:dPt>
+            <c:idx val="2"/>
+            <c:invertIfNegative val="0"/>
+            <c:bubble3D val="0"/>
+            <c:spPr>
+              <a:solidFill>
+                <a:srgbClr val="D9893B"/>
+              </a:solidFill>
+              <a:effectLst/>
+            </c:spPr>
+          </c:dPt>
+          <c:cat>
+            <c:multiLvlStrRef>
+              <c:f>Sheet1!$A$2:$A$4</c:f>
+              <c:multiLvlStrCache>
+                <c:ptCount val="3"/>
+                <c:lvl>
+                  <c:pt idx="0">
+                    <c:v>MiniRocket on the shape</c:v>
+                  </c:pt>
+                  <c:pt idx="1">
+                    <c:v>Size and noise alone</c:v>
+                  </c:pt>
+                  <c:pt idx="2">
+                    <c:v>Detector agreement</c:v>
+                  </c:pt>
+                </c:lvl>
+              </c:multiLvlStrCache>
+            </c:multiLvlStrRef>
+          </c:cat>
+          <c:val>
+            <c:numRef>
+              <c:f>Sheet1!$B$2:$B$4</c:f>
+              <c:numCache>
+                <c:formatCode>General</c:formatCode>
+                <c:ptCount val="3"/>
+                <c:pt idx="0">
+                  <c:v>0.97</c:v>
+                </c:pt>
+                <c:pt idx="1">
+                  <c:v>0.9</c:v>
+                </c:pt>
+                <c:pt idx="2">
+                  <c:v>0.86</c:v>
+                </c:pt>
+              </c:numCache>
+            </c:numRef>
+          </c:val>
+        </c:ser>
+        <c:dLbls>
+          <c:numFmt formatCode="0.00" sourceLinked="0"/>
+          <c:txPr>
+            <a:bodyPr/>
+            <a:lstStyle/>
+            <a:p>
+              <a:pPr>
+                <a:defRPr b="0" i="0" strike="noStrike" sz="1200" u="none">
+                  <a:solidFill>
+                    <a:srgbClr val="1F1A17"/>
+                  </a:solidFill>
+                  <a:latin typeface="+mn-lt"/>
+                </a:defRPr>
+              </a:pPr>
+            </a:p>
+          </c:txPr>
+          <c:showLegendKey val="0"/>
+          <c:showVal val="1"/>
+          <c:showCatName val="0"/>
+          <c:showSerName val="0"/>
+          <c:showPercent val="0"/>
+          <c:showBubbleSize val="0"/>
+          <c:showLeaderLines val="0"/>
+        </c:dLbls>
+        <c:gapWidth val="150"/>
+        <c:overlap val="0"/>
+        <c:axId val="2094734554"/>
+        <c:axId val="2094734552"/>
+        <c:axId val="2094734556"/>
+      </c:barChart>
+      <c:catAx>
+        <c:axId val="2094734554"/>
+        <c:scaling>
+          <c:orientation val="minMax"/>
+        </c:scaling>
+        <c:delete val="0"/>
+        <c:axPos val="l"/>
+        <c:numFmt formatCode="General" sourceLinked="1"/>
+        <c:majorTickMark val="out"/>
+        <c:minorTickMark val="none"/>
+        <c:tickLblPos val="nextTo"/>
+        <c:spPr>
+          <a:ln w="12700" cap="flat">
+            <a:solidFill>
+              <a:srgbClr val="888888"/>
+            </a:solidFill>
+            <a:prstDash val="solid"/>
+            <a:round/>
+          </a:ln>
+        </c:spPr>
+        <c:txPr>
+          <a:bodyPr/>
+          <a:lstStyle/>
+          <a:p>
+            <a:pPr>
+              <a:defRPr sz="1200" b="0" i="0" u="none" strike="noStrike">
+                <a:solidFill>
+                  <a:srgbClr val="5A5550"/>
+                </a:solidFill>
+                <a:latin typeface="+mn-lt"/>
+              </a:defRPr>
+            </a:pPr>
+            <a:endParaRPr lang="en-US"/>
+          </a:p>
+        </c:txPr>
+        <c:crossAx val="2094734552"/>
+        <c:crosses val="autoZero"/>
+        <c:auto val="1"/>
+        <c:lblAlgn val="ctr"/>
+        <c:noMultiLvlLbl val="1"/>
+      </c:catAx>
+      <c:valAx>
+        <c:axId val="2094734552"/>
+        <c:scaling>
+          <c:orientation val="minMax"/>
+          <c:max val="1"/>
+          <c:min val="0.5"/>
+        </c:scaling>
+        <c:delete val="0"/>
+        <c:axPos val="b"/>
+        <c:majorGridlines>
+          <c:spPr>
+            <a:ln w="6350" cap="flat">
+              <a:solidFill>
+                <a:srgbClr val="E3E6E3"/>
+              </a:solidFill>
+              <a:prstDash val="solid"/>
+              <a:round/>
+            </a:ln>
+          </c:spPr>
+        </c:majorGridlines>
+        <c:numFmt formatCode="0.0" sourceLinked="0"/>
+        <c:majorTickMark val="out"/>
+        <c:minorTickMark val="none"/>
+        <c:tickLblPos val="low"/>
+        <c:spPr>
+          <a:ln w="12700" cap="flat">
+            <a:solidFill>
+              <a:srgbClr val="888888"/>
+            </a:solidFill>
+            <a:prstDash val="solid"/>
+            <a:round/>
+          </a:ln>
+        </c:spPr>
+        <c:txPr>
+          <a:bodyPr/>
+          <a:lstStyle/>
+          <a:p>
+            <a:pPr>
+              <a:defRPr sz="1200" b="0" i="0" u="none" strike="noStrike">
+                <a:solidFill>
+                  <a:srgbClr val="5A5550"/>
+                </a:solidFill>
+                <a:latin typeface="+mn-lt"/>
+              </a:defRPr>
+            </a:pPr>
+            <a:endParaRPr lang="en-US"/>
+          </a:p>
+        </c:txPr>
+        <c:crossAx val="2094734554"/>
+        <c:crosses val="autoZero"/>
+        <c:crossBetween val="between"/>
+      </c:valAx>
+      <c:spPr>
+        <a:noFill/>
+        <a:ln>
+          <a:noFill/>
+        </a:ln>
+        <a:effectLst/>
+      </c:spPr>
+    </c:plotArea>
+    <c:plotVisOnly val="1"/>
+    <c:dispBlanksAs val="span"/>
+  </c:chart>
+  <c:spPr>
+    <a:noFill/>
+    <a:ln>
+      <a:noFill/>
+    </a:ln>
+    <a:effectLst/>
+  </c:spPr>
+  <c:externalData r:id="rId1">
+    <c:autoUpdate val="0"/>
+  </c:externalData>
+</c:chartSpace>
+</file>
+
 <file path=ppt/notesMasters/notesMaster1.xml><?xml version="1.0" encoding="utf-8"?>
 <p:notesMaster xmlns:a="http://schemas.openxmlformats.org/drawingml/2006/main" xmlns:r="http://schemas.openxmlformats.org/officeDocument/2006/relationships" xmlns:p="http://schemas.openxmlformats.org/presentationml/2006/main">
   <p:cSld>
@@ -2454,7 +2758,7 @@
           <a:p>
             <a:r>
               <a:rPr lang="en-US" dirty="0"/>
-              <a:t>Source: docs/rq_roundA_2/findings/rq1b-minirocket-preliminary.md and its ROC figure. Preliminary: not the family classifier, not the exam recording.</a:t>
+              <a:t>Source: docs/rq_roundA_2/findings/rq1b-minirocket-2026-10-20.md (model DATA/derived/models/rq1b_minirocket/20261020-2343). On the 1,689 stratified queue candidates (queues 25 and 28): MiniRocket balanced accuracy 0.92, AUC 0.97; size and noise alone 0.85 / 0.90; detector agreement AUC 0.86. Classes: interesting (with seed) vs not interesting; M4_aug (the exam recording) was left out. Supersedes the queue-25-only preliminary (0.79 vs 0.83).</a:t>
             </a:r>
             <a:endParaRPr lang="en-US" dirty="0"/>
           </a:p>
@@ -5981,7 +6285,7 @@
                   <a:schemeClr val="bg1"/>
                 </a:solidFill>
               </a:rPr>
-              <a:t>R1 where each algorithm fires · R2 seeded search · R3 how many candidates are real · R4 shape vs agreement</a:t>
+              <a:t>R1 where each algorithm fires · R2 seeded search · R3 how many candidates are real · R4 a classifier of your verdicts</a:t>
             </a:r>
             <a:endParaRPr lang="en-US" sz="1800" dirty="0"/>
           </a:p>
@@ -6959,36 +7263,28 @@
                   <a:schemeClr val="tx1"/>
                 </a:solidFill>
               </a:rPr>
-              <a:t>R4 · Shape alone does not beat the vote yet</a:t>
+              <a:t>R4 · Shape now beats the detectors’ vote</a:t>
             </a:r>
             <a:endParaRPr lang="en-US" sz="2800" dirty="0"/>
           </a:p>
         </p:txBody>
       </p:sp>
-      <p:pic>
-        <p:nvPicPr>
-          <p:cNvPr id="3" name="roc" descr="ROC curves: MiniRocket vs agreement count">    </p:cNvPr>
-          <p:cNvPicPr>
-            <a:picLocks noChangeAspect="1"/>
-          </p:cNvPicPr>
+      <p:graphicFrame>
+        <p:nvGraphicFramePr>
+          <p:cNvPr id="3" name="Chart 0" descr=""/>
+          <p:cNvGraphicFramePr/>
           <p:nvPr/>
-        </p:nvPicPr>
-        <p:blipFill>
-          <a:blip r:embed="rId1"/>
-          <a:stretch>
-            <a:fillRect/>
-          </a:stretch>
-        </p:blipFill>
-        <p:spPr>
-          <a:xfrm>
-            <a:off x="457200" y="1005840"/>
-            <a:ext cx="4251960" cy="3657600"/>
-          </a:xfrm>
-          <a:prstGeom prst="rect">
-            <a:avLst/>
-          </a:prstGeom>
-        </p:spPr>
-      </p:pic>
+        </p:nvGraphicFramePr>
+        <p:xfrm>
+          <a:off x="457200" y="1051560"/>
+          <a:ext cx="4937760" cy="3566160"/>
+        </p:xfrm>
+        <a:graphic xmlns:a="http://schemas.openxmlformats.org/drawingml/2006/main">
+          <a:graphicData uri="http://schemas.openxmlformats.org/drawingml/2006/chart">
+            <c:chart xmlns:c="http://schemas.openxmlformats.org/drawingml/2006/chart" r:id="rId1"/>
+          </a:graphicData>
+        </a:graphic>
+      </p:graphicFrame>
       <p:sp>
         <p:nvSpPr>
           <p:cNvPr id="4" name="Text 1"/>
@@ -6997,8 +7293,8 @@
         </p:nvSpPr>
         <p:spPr>
           <a:xfrm>
-            <a:off x="5120640" y="1097280"/>
-            <a:ext cx="1371600" cy="640080"/>
+            <a:off x="5760720" y="1097280"/>
+            <a:ext cx="2926080" cy="731520"/>
           </a:xfrm>
           <a:prstGeom prst="rect">
             <a:avLst/>
@@ -7007,14 +7303,14 @@
           <a:ln/>
         </p:spPr>
         <p:txBody>
-          <a:bodyPr wrap="square" lIns="0" tIns="0" rIns="0" bIns="0" rtlCol="0" anchor="ctr"/>
+          <a:bodyPr wrap="square" lIns="0" tIns="0" rIns="0" bIns="0" rtlCol="0" anchor="t"/>
           <a:lstStyle/>
           <a:p>
             <a:pPr indent="0" marL="0">
               <a:buNone/>
             </a:pPr>
             <a:r>
-              <a:rPr lang="en-US" sz="3600" b="1" dirty="0">
+              <a:rPr lang="en-US" sz="4000" b="1" dirty="0">
                 <a:solidFill>
                   <a:schemeClr val="accent1"/>
                 </a:solidFill>
@@ -7022,9 +7318,9 @@
                 <a:ea typeface="Cambria" pitchFamily="34" charset="-122"/>
                 <a:cs typeface="Cambria" pitchFamily="34" charset="-120"/>
               </a:rPr>
-              <a:t>0.83</a:t>
-            </a:r>
-            <a:endParaRPr lang="en-US" sz="3600" dirty="0"/>
+              <a:t>0.97</a:t>
+            </a:r>
+            <a:endParaRPr lang="en-US" sz="4000" dirty="0"/>
           </a:p>
         </p:txBody>
       </p:sp>
@@ -7036,8 +7332,8 @@
         </p:nvSpPr>
         <p:spPr>
           <a:xfrm>
-            <a:off x="6537960" y="1097280"/>
-            <a:ext cx="2194560" cy="640080"/>
+            <a:off x="5760720" y="1828800"/>
+            <a:ext cx="2926080" cy="822960"/>
           </a:xfrm>
           <a:prstGeom prst="rect">
             <a:avLst/>
@@ -7046,7 +7342,7 @@
           <a:ln/>
         </p:spPr>
         <p:txBody>
-          <a:bodyPr wrap="square" lIns="0" tIns="0" rIns="0" bIns="0" rtlCol="0" anchor="ctr"/>
+          <a:bodyPr wrap="square" lIns="0" tIns="0" rIns="0" bIns="0" rtlCol="0" anchor="t"/>
           <a:lstStyle/>
           <a:p>
             <a:pPr indent="0" marL="0">
@@ -7058,7 +7354,7 @@
                   <a:schemeClr val="tx1"/>
                 </a:solidFill>
               </a:rPr>
-              <a:t>AUC · detector agreement count</a:t>
+              <a:t>AUC on recordings it never saw (balanced accuracy 0.92); 0.95–0.99 for each recording held out in turn</a:t>
             </a:r>
             <a:endParaRPr lang="en-US" sz="1300" dirty="0"/>
           </a:p>
@@ -7072,8 +7368,8 @@
         </p:nvSpPr>
         <p:spPr>
           <a:xfrm>
-            <a:off x="5120640" y="1828800"/>
-            <a:ext cx="1371600" cy="640080"/>
+            <a:off x="5760720" y="2743200"/>
+            <a:ext cx="2926080" cy="1828800"/>
           </a:xfrm>
           <a:prstGeom prst="rect">
             <a:avLst/>
@@ -7082,169 +7378,19 @@
           <a:ln/>
         </p:spPr>
         <p:txBody>
-          <a:bodyPr wrap="square" lIns="0" tIns="0" rIns="0" bIns="0" rtlCol="0" anchor="ctr"/>
+          <a:bodyPr wrap="square" lIns="0" tIns="0" rIns="0" bIns="0" rtlCol="0" anchor="t"/>
           <a:lstStyle/>
           <a:p>
             <a:pPr indent="0" marL="0">
               <a:buNone/>
             </a:pPr>
             <a:r>
-              <a:rPr lang="en-US" sz="3600" b="1" dirty="0">
-                <a:solidFill>
-                  <a:schemeClr val="accent2"/>
-                </a:solidFill>
-                <a:latin typeface="Cambria" pitchFamily="34" charset="0"/>
-                <a:ea typeface="Cambria" pitchFamily="34" charset="-122"/>
-                <a:cs typeface="Cambria" pitchFamily="34" charset="-120"/>
+              <a:rPr lang="en-US" sz="1200" dirty="0">
+                <a:solidFill>
+                  <a:schemeClr val="tx2"/>
+                </a:solidFill>
               </a:rPr>
-              <a:t>0.79</a:t>
-            </a:r>
-            <a:endParaRPr lang="en-US" sz="3600" dirty="0"/>
-          </a:p>
-        </p:txBody>
-      </p:sp>
-      <p:sp>
-        <p:nvSpPr>
-          <p:cNvPr id="7" name="Text 4"/>
-          <p:cNvSpPr txBox="1"/>
-          <p:nvPr/>
-        </p:nvSpPr>
-        <p:spPr>
-          <a:xfrm>
-            <a:off x="6537960" y="1828800"/>
-            <a:ext cx="2194560" cy="640080"/>
-          </a:xfrm>
-          <a:prstGeom prst="rect">
-            <a:avLst/>
-          </a:prstGeom>
-          <a:noFill/>
-          <a:ln/>
-        </p:spPr>
-        <p:txBody>
-          <a:bodyPr wrap="square" lIns="0" tIns="0" rIns="0" bIns="0" rtlCol="0" anchor="ctr"/>
-          <a:lstStyle/>
-          <a:p>
-            <a:pPr indent="0" marL="0">
-              <a:buNone/>
-            </a:pPr>
-            <a:r>
-              <a:rPr lang="en-US" sz="1300" dirty="0">
-                <a:solidFill>
-                  <a:schemeClr val="tx1"/>
-                </a:solidFill>
-              </a:rPr>
-              <a:t>AUC · MiniRocket on the trace’s shape</a:t>
-            </a:r>
-            <a:endParaRPr lang="en-US" sz="1300" dirty="0"/>
-          </a:p>
-        </p:txBody>
-      </p:sp>
-      <p:sp>
-        <p:nvSpPr>
-          <p:cNvPr id="8" name="Text 5"/>
-          <p:cNvSpPr txBox="1"/>
-          <p:nvPr/>
-        </p:nvSpPr>
-        <p:spPr>
-          <a:xfrm>
-            <a:off x="5120640" y="2560320"/>
-            <a:ext cx="1371600" cy="640080"/>
-          </a:xfrm>
-          <a:prstGeom prst="rect">
-            <a:avLst/>
-          </a:prstGeom>
-          <a:noFill/>
-          <a:ln/>
-        </p:spPr>
-        <p:txBody>
-          <a:bodyPr wrap="square" lIns="0" tIns="0" rIns="0" bIns="0" rtlCol="0" anchor="ctr"/>
-          <a:lstStyle/>
-          <a:p>
-            <a:pPr indent="0" marL="0">
-              <a:buNone/>
-            </a:pPr>
-            <a:r>
-              <a:rPr lang="en-US" sz="3600" b="1" dirty="0">
-                <a:solidFill>
-                  <a:schemeClr val="accent6"/>
-                </a:solidFill>
-                <a:latin typeface="Cambria" pitchFamily="34" charset="0"/>
-                <a:ea typeface="Cambria" pitchFamily="34" charset="-122"/>
-                <a:cs typeface="Cambria" pitchFamily="34" charset="-120"/>
-              </a:rPr>
-              <a:t>0.82</a:t>
-            </a:r>
-            <a:endParaRPr lang="en-US" sz="3600" dirty="0"/>
-          </a:p>
-        </p:txBody>
-      </p:sp>
-      <p:sp>
-        <p:nvSpPr>
-          <p:cNvPr id="9" name="Text 6"/>
-          <p:cNvSpPr txBox="1"/>
-          <p:nvPr/>
-        </p:nvSpPr>
-        <p:spPr>
-          <a:xfrm>
-            <a:off x="6537960" y="2560320"/>
-            <a:ext cx="2194560" cy="640080"/>
-          </a:xfrm>
-          <a:prstGeom prst="rect">
-            <a:avLst/>
-          </a:prstGeom>
-          <a:noFill/>
-          <a:ln/>
-        </p:spPr>
-        <p:txBody>
-          <a:bodyPr wrap="square" lIns="0" tIns="0" rIns="0" bIns="0" rtlCol="0" anchor="ctr"/>
-          <a:lstStyle/>
-          <a:p>
-            <a:pPr indent="0" marL="0">
-              <a:buNone/>
-            </a:pPr>
-            <a:r>
-              <a:rPr lang="en-US" sz="1300" dirty="0">
-                <a:solidFill>
-                  <a:schemeClr val="tx1"/>
-                </a:solidFill>
-              </a:rPr>
-              <a:t>AUC · both together</a:t>
-            </a:r>
-            <a:endParaRPr lang="en-US" sz="1300" dirty="0"/>
-          </a:p>
-        </p:txBody>
-      </p:sp>
-      <p:sp>
-        <p:nvSpPr>
-          <p:cNvPr id="10" name="Text 7"/>
-          <p:cNvSpPr txBox="1"/>
-          <p:nvPr/>
-        </p:nvSpPr>
-        <p:spPr>
-          <a:xfrm>
-            <a:off x="5120640" y="3383280"/>
-            <a:ext cx="3566160" cy="1280160"/>
-          </a:xfrm>
-          <a:prstGeom prst="rect">
-            <a:avLst/>
-          </a:prstGeom>
-          <a:noFill/>
-          <a:ln/>
-        </p:spPr>
-        <p:txBody>
-          <a:bodyPr wrap="square" lIns="0" tIns="0" rIns="0" bIns="0" rtlCol="0" anchor="t"/>
-          <a:lstStyle/>
-          <a:p>
-            <a:pPr indent="0" marL="0">
-              <a:buNone/>
-            </a:pPr>
-            <a:r>
-              <a:rPr lang="en-US" sz="1200" dirty="0">
-                <a:solidFill>
-                  <a:schemeClr val="tx2"/>
-                </a:solidFill>
-              </a:rPr>
-              <a:t>On 722 blind verdicts (queue 25). The labels are few for MiniRocket, and "interesting or not" is what agreement measures well; the family classifier needs class labels and more examples, and that is the next step.</a:t>
+              <a:t>Trained on 2,456 judged events and 3,000 windows from five recordings, each held out in turn. It still separates interesting from not within each detector family (AUC 0.88–0.99), so it judges the shape, not which detector found it.</a:t>
             </a:r>
             <a:endParaRPr lang="en-US" sz="1200" dirty="0"/>
           </a:p>

</xml_diff>